<commit_message>
changed naming of test sets to fit better to scaling tiers and cores
</commit_message>
<xml_diff>
--- a/Perf Test Harness-Overview.pptx
+++ b/Perf Test Harness-Overview.pptx
@@ -134,10 +134,6 @@
 </p:presentation>
 </file>
 
-<file path=ppt/revisionInfo.xml><?xml version="1.0" encoding="utf-8"?>
-<p1510:revInfo xmlns:a="http://schemas.openxmlformats.org/drawingml/2006/main" xmlns:r="http://schemas.openxmlformats.org/officeDocument/2006/relationships" xmlns:p1510="http://schemas.microsoft.com/office/powerpoint/2015/10/main"/>
-</file>
-
 <file path=ppt/notesMasters/notesMaster1.xml><?xml version="1.0" encoding="utf-8"?>
 <p:notesMaster xmlns:a="http://schemas.openxmlformats.org/drawingml/2006/main" xmlns:r="http://schemas.openxmlformats.org/officeDocument/2006/relationships" xmlns:p="http://schemas.openxmlformats.org/presentationml/2006/main">
   <p:cSld>
@@ -220,7 +216,7 @@
           <a:p>
             <a:fld id="{2A4B08CC-DC44-4989-87E5-2A014D8E7470}" type="datetimeFigureOut">
               <a:rPr lang="en-US" smtClean="0"/>
-              <a:t>12/7/2017</a:t>
+              <a:t>8/17/2020</a:t>
             </a:fld>
             <a:endParaRPr lang="en-US"/>
           </a:p>
@@ -7395,15 +7391,12 @@
           <a:bodyPr/>
           <a:lstStyle/>
           <a:p>
+            <a:endParaRPr lang="en-US" dirty="0"/>
+          </a:p>
+          <a:p>
             <a:r>
               <a:rPr lang="en-US" dirty="0"/>
               <a:t>Christian Holtfurth</a:t>
-            </a:r>
-          </a:p>
-          <a:p>
-            <a:r>
-              <a:rPr lang="en-US" dirty="0"/>
-              <a:t>PSG Knowledge Sharing Session</a:t>
             </a:r>
           </a:p>
           <a:p>
@@ -8966,8 +8959,8 @@
         </p:nvSpPr>
         <p:spPr bwMode="auto">
           <a:xfrm>
-            <a:off x="2411484" y="1531456"/>
-            <a:ext cx="7369031" cy="3108543"/>
+            <a:off x="2411484" y="1962342"/>
+            <a:ext cx="7369031" cy="2246769"/>
           </a:xfrm>
           <a:prstGeom prst="rect">
             <a:avLst/>
@@ -9176,77 +9169,6 @@
               </a:rPr>
               <a:t>one</a:t>
             </a:r>
-          </a:p>
-          <a:p>
-            <a:pPr marL="0" marR="0" lvl="0" indent="0" algn="l" defTabSz="914400" rtl="0" eaLnBrk="0" fontAlgn="base" latinLnBrk="0" hangingPunct="0">
-              <a:lnSpc>
-                <a:spcPct val="100000"/>
-              </a:lnSpc>
-              <a:spcBef>
-                <a:spcPct val="0"/>
-              </a:spcBef>
-              <a:spcAft>
-                <a:spcPct val="0"/>
-              </a:spcAft>
-              <a:buClrTx/>
-              <a:buSzTx/>
-              <a:buFontTx/>
-              <a:buNone/>
-              <a:tabLst/>
-            </a:pPr>
-            <a:endParaRPr lang="en-US" altLang="en-US" dirty="0">
-              <a:solidFill>
-                <a:schemeClr val="bg1">
-                  <a:lumMod val="85000"/>
-                </a:schemeClr>
-              </a:solidFill>
-              <a:latin typeface="Arial Unicode MS" panose="020B0604020202020204" pitchFamily="34" charset="-128"/>
-            </a:endParaRPr>
-          </a:p>
-          <a:p>
-            <a:pPr marL="0" marR="0" lvl="0" indent="0" algn="l" defTabSz="914400" rtl="0" eaLnBrk="0" fontAlgn="base" latinLnBrk="0" hangingPunct="0">
-              <a:lnSpc>
-                <a:spcPct val="100000"/>
-              </a:lnSpc>
-              <a:spcBef>
-                <a:spcPct val="0"/>
-              </a:spcBef>
-              <a:spcAft>
-                <a:spcPct val="0"/>
-              </a:spcAft>
-              <a:buClrTx/>
-              <a:buSzTx/>
-              <a:buFontTx/>
-              <a:buNone/>
-              <a:tabLst/>
-            </a:pPr>
-            <a:r>
-              <a:rPr kumimoji="0" lang="en-US" altLang="en-US" b="0" i="0" u="none" strike="noStrike" cap="none" normalizeH="0" baseline="0" dirty="0" err="1">
-                <a:ln>
-                  <a:noFill/>
-                </a:ln>
-                <a:solidFill>
-                  <a:schemeClr val="bg1">
-                    <a:lumMod val="85000"/>
-                  </a:schemeClr>
-                </a:solidFill>
-                <a:effectLst/>
-                <a:latin typeface="Arial Unicode MS" panose="020B0604020202020204" pitchFamily="34" charset="-128"/>
-              </a:rPr>
-              <a:t>Initiate_demo</a:t>
-            </a:r>
-            <a:endParaRPr kumimoji="0" lang="en-US" altLang="en-US" b="0" i="0" u="none" strike="noStrike" cap="none" normalizeH="0" baseline="0" dirty="0">
-              <a:ln>
-                <a:noFill/>
-              </a:ln>
-              <a:solidFill>
-                <a:schemeClr val="bg1">
-                  <a:lumMod val="85000"/>
-                </a:schemeClr>
-              </a:solidFill>
-              <a:effectLst/>
-              <a:latin typeface="Arial Unicode MS" panose="020B0604020202020204" pitchFamily="34" charset="-128"/>
-            </a:endParaRPr>
           </a:p>
         </p:txBody>
       </p:sp>
@@ -9301,41 +9223,41 @@
           <a:lstStyle/>
           <a:p>
             <a:r>
-              <a:rPr lang="en-US" dirty="0"/>
-              <a:t>The customer wants a sizing guide for VMRs in the cloud!</a:t>
-            </a:r>
-          </a:p>
-          <a:p>
-            <a:r>
-              <a:rPr lang="en-US" dirty="0"/>
-              <a:t>Gathering a full set of performance metrics on a VMR takes a lot of time:</a:t>
+              <a:rPr lang="en-US" sz="2400" dirty="0"/>
+              <a:t>The customer wants to know what kind of performance a broker can achieve on given infrastructure (on-prem/cloud)!</a:t>
+            </a:r>
+          </a:p>
+          <a:p>
+            <a:r>
+              <a:rPr lang="en-US" sz="2400" dirty="0"/>
+              <a:t>Gathering a full set of performance metrics on a broker takes a lot of time:</a:t>
             </a:r>
           </a:p>
           <a:p>
             <a:pPr lvl="1"/>
             <a:r>
-              <a:rPr lang="en-US" dirty="0"/>
+              <a:rPr lang="en-US" sz="2000" dirty="0"/>
               <a:t>Lot of tests with varying message sizes and fan-out ratios as well as different message types</a:t>
             </a:r>
           </a:p>
           <a:p>
             <a:pPr lvl="1"/>
             <a:r>
-              <a:rPr lang="en-US" dirty="0"/>
+              <a:rPr lang="en-US" sz="2000" dirty="0"/>
               <a:t>Each test needs to be run for a min amount of time to make sure we are not spooling etc.</a:t>
             </a:r>
           </a:p>
           <a:p>
             <a:pPr lvl="1"/>
             <a:r>
-              <a:rPr lang="en-US" dirty="0"/>
+              <a:rPr lang="en-US" sz="2000" dirty="0"/>
               <a:t>Lot of virtual hardware sizes to choose from and run tests on</a:t>
             </a:r>
           </a:p>
           <a:p>
             <a:pPr lvl="1"/>
             <a:r>
-              <a:rPr lang="en-US" dirty="0"/>
+              <a:rPr lang="en-US" sz="2000" dirty="0"/>
               <a:t>Sdkperf needs to be run across several hosts spreading traffic across several topics</a:t>
             </a:r>
           </a:p>

</xml_diff>